<commit_message>
Week 8: learning-rate animation on slide 11; add 10 watched-and-transcribed video clips to L1/L2 slides and handouts
Co-Authored-By: Claude Opus 5.5 <noreply@anthropic.com>
</commit_message>
<xml_diff>
--- a/第八週(10-29)/第八週_第2節_簡報.pptx
+++ b/第八週(10-29)/第八週_第2節_簡報.pptx
@@ -2010,11 +2010,11 @@
                 <a:spcPts val="0"/>
               </a:spcBef>
               <a:spcAft>
-                <a:spcPts val="233"/>
+                <a:spcPts val="208"/>
               </a:spcAft>
             </a:pPr>
             <a:r>
-              <a:rPr sz="1400" b="1" lang="zh-TW" dirty="0">
+              <a:rPr sz="1250" b="1" lang="zh-TW" dirty="0">
                 <a:solidFill>
                   <a:srgbClr val="000000"/>
                 </a:solidFill>
@@ -2025,7 +2025,7 @@
               <a:t>這一張的目的：</a:t>
             </a:r>
             <a:r>
-              <a:rPr sz="1400" lang="zh-TW" dirty="0">
+              <a:rPr sz="1250" lang="zh-TW" dirty="0">
                 <a:solidFill>
                   <a:srgbClr val="000000"/>
                 </a:solidFill>
@@ -2043,11 +2043,11 @@
                 <a:spcPts val="0"/>
               </a:spcBef>
               <a:spcAft>
-                <a:spcPts val="233"/>
+                <a:spcPts val="208"/>
               </a:spcAft>
             </a:pPr>
             <a:r>
-              <a:rPr sz="1400" lang="zh-TW" dirty="0">
+              <a:rPr sz="1250" lang="zh-TW" dirty="0">
                 <a:solidFill>
                   <a:srgbClr val="000000"/>
                 </a:solidFill>
@@ -2065,11 +2065,11 @@
                 <a:spcPts val="0"/>
               </a:spcBef>
               <a:spcAft>
-                <a:spcPts val="233"/>
+                <a:spcPts val="208"/>
               </a:spcAft>
             </a:pPr>
             <a:r>
-              <a:rPr sz="1400" b="1" lang="zh-TW" dirty="0">
+              <a:rPr sz="1250" b="1" lang="zh-TW" dirty="0">
                 <a:solidFill>
                   <a:srgbClr val="000000"/>
                 </a:solidFill>
@@ -2080,7 +2080,7 @@
               <a:t>第一條：有一個光達或雷達點就要標。</a:t>
             </a:r>
             <a:r>
-              <a:rPr sz="1400" lang="zh-TW" dirty="0">
+              <a:rPr sz="1250" lang="zh-TW" dirty="0">
                 <a:solidFill>
                   <a:srgbClr val="000000"/>
                 </a:solidFill>
@@ -2098,11 +2098,11 @@
                 <a:spcPts val="0"/>
               </a:spcBef>
               <a:spcAft>
-                <a:spcPts val="233"/>
+                <a:spcPts val="208"/>
               </a:spcAft>
             </a:pPr>
             <a:r>
-              <a:rPr sz="1400" b="1" lang="zh-TW" dirty="0">
+              <a:rPr sz="1250" b="1" lang="zh-TW" dirty="0">
                 <a:solidFill>
                   <a:srgbClr val="000000"/>
                 </a:solidFill>
@@ -2113,7 +2113,7 @@
               <a:t>第二條：框要很貼。</a:t>
             </a:r>
             <a:r>
-              <a:rPr sz="1400" lang="zh-TW" dirty="0">
+              <a:rPr sz="1250" lang="zh-TW" dirty="0">
                 <a:solidFill>
                   <a:srgbClr val="000000"/>
                 </a:solidFill>
@@ -2131,11 +2131,11 @@
                 <a:spcPts val="0"/>
               </a:spcBef>
               <a:spcAft>
-                <a:spcPts val="233"/>
+                <a:spcPts val="208"/>
               </a:spcAft>
             </a:pPr>
             <a:r>
-              <a:rPr sz="1400" b="1" lang="zh-TW" dirty="0">
+              <a:rPr sz="1250" b="1" lang="zh-TW" dirty="0">
                 <a:solidFill>
                   <a:srgbClr val="000000"/>
                 </a:solidFill>
@@ -2146,7 +2146,7 @@
               <a:t>第三條：手腳要包進去。</a:t>
             </a:r>
             <a:r>
-              <a:rPr sz="1400" lang="zh-TW" dirty="0">
+              <a:rPr sz="1250" lang="zh-TW" dirty="0">
                 <a:solidFill>
                   <a:srgbClr val="000000"/>
                 </a:solidFill>
@@ -2164,11 +2164,11 @@
                 <a:spcPts val="0"/>
               </a:spcBef>
               <a:spcAft>
-                <a:spcPts val="233"/>
+                <a:spcPts val="208"/>
               </a:spcAft>
             </a:pPr>
             <a:r>
-              <a:rPr sz="1400" b="1" lang="zh-TW" dirty="0">
+              <a:rPr sz="1250" b="1" lang="zh-TW" dirty="0">
                 <a:solidFill>
                   <a:srgbClr val="000000"/>
                 </a:solidFill>
@@ -2179,7 +2179,7 @@
               <a:t>第四條、第五條，騎士。</a:t>
             </a:r>
             <a:r>
-              <a:rPr sz="1400" lang="zh-TW" dirty="0">
+              <a:rPr sz="1250" lang="zh-TW" dirty="0">
                 <a:solidFill>
                   <a:srgbClr val="000000"/>
                 </a:solidFill>
@@ -2190,7 +2190,7 @@
               <a:t>機車、腳踏車有人騎，</a:t>
             </a:r>
             <a:r>
-              <a:rPr sz="1400" b="1" lang="zh-TW" dirty="0">
+              <a:rPr sz="1250" b="1" lang="zh-TW" dirty="0">
                 <a:solidFill>
                   <a:srgbClr val="000000"/>
                 </a:solidFill>
@@ -2201,7 +2201,7 @@
               <a:t>騎士跟車框在同一個框裡</a:t>
             </a:r>
             <a:r>
-              <a:rPr sz="1400" lang="zh-TW" dirty="0">
+              <a:rPr sz="1250" lang="zh-TW" dirty="0">
                 <a:solidFill>
                   <a:srgbClr val="000000"/>
                 </a:solidFill>
@@ -2212,7 +2212,7 @@
               <a:t>；可是旁邊站著、沒有騎的人，</a:t>
             </a:r>
             <a:r>
-              <a:rPr sz="1400" b="1" lang="zh-TW" dirty="0">
+              <a:rPr sz="1250" b="1" lang="zh-TW" dirty="0">
                 <a:solidFill>
                   <a:srgbClr val="000000"/>
                 </a:solidFill>
@@ -2223,7 +2223,7 @@
               <a:t>不要包進去</a:t>
             </a:r>
             <a:r>
-              <a:rPr sz="1400" lang="zh-TW" dirty="0">
+              <a:rPr sz="1250" lang="zh-TW" dirty="0">
                 <a:solidFill>
                   <a:srgbClr val="000000"/>
                 </a:solidFill>
@@ -2241,11 +2241,11 @@
                 <a:spcPts val="0"/>
               </a:spcBef>
               <a:spcAft>
-                <a:spcPts val="233"/>
+                <a:spcPts val="208"/>
               </a:spcAft>
             </a:pPr>
             <a:r>
-              <a:rPr sz="1400" b="1" lang="zh-TW" dirty="0">
+              <a:rPr sz="1250" b="1" lang="zh-TW" dirty="0">
                 <a:solidFill>
                   <a:srgbClr val="000000"/>
                 </a:solidFill>
@@ -2256,7 +2256,7 @@
               <a:t>第六條：可見度分四級。</a:t>
             </a:r>
             <a:r>
-              <a:rPr sz="1400" lang="zh-TW" dirty="0">
+              <a:rPr sz="1250" lang="zh-TW" dirty="0">
                 <a:solidFill>
                   <a:srgbClr val="000000"/>
                 </a:solidFill>
@@ -2274,19 +2274,52 @@
                 <a:spcPts val="0"/>
               </a:spcBef>
               <a:spcAft>
-                <a:spcPts val="233"/>
+                <a:spcPts val="208"/>
               </a:spcAft>
             </a:pPr>
             <a:r>
-              <a:rPr sz="1400" lang="zh-TW" dirty="0">
-                <a:solidFill>
-                  <a:srgbClr val="000000"/>
-                </a:solidFill>
-                <a:latin typeface="Arial Unicode MS"/>
-                <a:ea typeface="Arial Unicode MS"/>
-                <a:cs typeface="Arial Unicode MS"/>
-              </a:rPr>
-              <a:t>注意，nuScenes 標的是立體框，今天我們在照片上標平面框，比較簡單，但規則的精神一樣。網頁右邊也寫了一份今天的規則。</a:t>
+              <a:rPr sz="1250" lang="zh-TW" dirty="0">
+                <a:solidFill>
+                  <a:srgbClr val="000000"/>
+                </a:solidFill>
+                <a:latin typeface="Arial Unicode MS"/>
+                <a:ea typeface="Arial Unicode MS"/>
+                <a:cs typeface="Arial Unicode MS"/>
+              </a:rPr>
+              <a:t>注意，nuScenes 標的是立體框，今天我們在照片上標平面框，比較簡單，但規則的精神一樣。網頁右邊也寫了一份今天的規則。
+</a:t>
+            </a:r>
+          </a:p>
+          <a:p>
+            <a:pPr algn="l">
+              <a:spcBef>
+                <a:spcPts val="0"/>
+              </a:spcBef>
+              <a:spcAft>
+                <a:spcPts val="208"/>
+              </a:spcAft>
+            </a:pPr>
+            <a:r>
+              <a:rPr sz="1250" b="1" lang="zh-TW" dirty="0">
+                <a:solidFill>
+                  <a:srgbClr val="000000"/>
+                </a:solidFill>
+                <a:latin typeface="Arial Unicode MS"/>
+                <a:ea typeface="Arial Unicode MS"/>
+                <a:cs typeface="Arial Unicode MS"/>
+              </a:rPr>
+              <a:t>影片（CVAT 官方教學，英文，可開自動翻譯字幕）：從 0:16 播到 2:47。</a:t>
+            </a:r>
+            <a:r>
+              <a:rPr sz="1250" lang="zh-TW" dirty="0">
+                <a:solidFill>
+                  <a:srgbClr val="000000"/>
+                </a:solidFill>
+                <a:latin typeface="Arial Unicode MS"/>
+                <a:ea typeface="Arial Unicode MS"/>
+                <a:cs typeface="Arial Unicode MS"/>
+              </a:rPr>
+              <a:t>CVAT 是一套免費、開放原始碼的標註軟體，很多公司真的用它標資料。畫面是一條下雨的街道，有行人和車。他示範兩種畫框的方法：點兩個角（0:43），或點上下左右四個點，形狀奇怪的東西比較準（1:20）；畫好可以拖曳、拉邊調大小（1:48）；2:35 有一個「occluded（被擋住）」的勾選，就是我們表上的可見度。等一下各位用的練習台是簡化版，原理一樣。</a:t>
             </a:r>
           </a:p>
         </p:txBody>
@@ -7277,7 +7310,7 @@
       </p:nvGrpSpPr>
       <p:grpSpPr>
         <a:xfrm>
-          <a:off x="680837" y="0"/>
+          <a:off x="0" y="0"/>
           <a:ext cx="1" cy="1"/>
           <a:chOff x="0" y="0"/>
           <a:chExt cx="0" cy="0"/>
@@ -7291,8 +7324,8 @@
         </p:nvSpPr>
         <p:spPr>
           <a:xfrm>
-            <a:off x="1108865" y="249034"/>
-            <a:ext cx="6926270" cy="715974"/>
+            <a:off x="502920" y="292608"/>
+            <a:ext cx="8138160" cy="841248"/>
           </a:xfrm>
           <a:prstGeom prst="rect">
             <a:avLst/>
@@ -7311,7 +7344,7 @@
               <a:buNone/>
             </a:pPr>
             <a:r>
-              <a:rPr lang="en-US" sz="1870" b="1" dirty="0">
+              <a:rPr lang="en-US" sz="2200" b="1" dirty="0">
                 <a:solidFill>
                   <a:srgbClr val="0B1F3A"/>
                 </a:solidFill>
@@ -7321,7 +7354,7 @@
               </a:rPr>
               <a:t>Quy tắc gán nhãn chính thức của nuScenes (trích)</a:t>
             </a:r>
-            <a:endParaRPr lang="en-US" sz="1870" dirty="0"/>
+            <a:endParaRPr lang="en-US" sz="2200" dirty="0"/>
           </a:p>
           <a:p>
             <a:pPr indent="0" marL="0">
@@ -7331,7 +7364,7 @@
               <a:buNone/>
             </a:pPr>
             <a:r>
-              <a:rPr lang="en-US" sz="1150" dirty="0">
+              <a:rPr lang="en-US" sz="1350" dirty="0">
                 <a:solidFill>
                   <a:srgbClr val="5F7183"/>
                 </a:solidFill>
@@ -7341,7 +7374,7 @@
               </a:rPr>
               <a:t>nuScenes 官方標註規則（節錄）</a:t>
             </a:r>
-            <a:endParaRPr lang="en-US" sz="1870" dirty="0"/>
+            <a:endParaRPr lang="en-US" sz="2200" dirty="0"/>
           </a:p>
         </p:txBody>
       </p:sp>
@@ -7360,19 +7393,19 @@
           </p:nvPr>
         </p:nvGraphicFramePr>
         <p:xfrm>
-          <a:off x="1108865" y="965008"/>
-          <a:ext cx="6926270" cy="778233"/>
+          <a:off x="502920" y="1133856"/>
+          <a:ext cx="8138160" cy="914400"/>
         </p:xfrm>
         <a:graphic>
           <a:graphicData uri="http://schemas.openxmlformats.org/drawingml/2006/table">
             <a:tbl>
               <a:tblPr/>
               <a:tblGrid>
-                <a:gridCol w="2023405"/>
-                <a:gridCol w="2645991"/>
-                <a:gridCol w="2256874"/>
+                <a:gridCol w="2377440"/>
+                <a:gridCol w="3108960"/>
+                <a:gridCol w="2651760"/>
               </a:tblGrid>
-              <a:tr h="326858">
+              <a:tr h="274320">
                 <a:tc>
                   <a:txBody>
                     <a:bodyPr/>
@@ -7382,7 +7415,7 @@
                         <a:buNone/>
                       </a:pPr>
                       <a:r>
-                        <a:rPr lang="en-US" sz="890" b="1" dirty="0">
+                        <a:rPr lang="en-US" sz="950" b="1" dirty="0">
                           <a:solidFill>
                             <a:srgbClr val="FFFFFF"/>
                           </a:solidFill>
@@ -7392,14 +7425,14 @@
                         </a:rPr>
                         <a:t>Quy tắc</a:t>
                       </a:r>
-                      <a:endParaRPr lang="en-US" sz="1020" dirty="0"/>
+                      <a:endParaRPr lang="en-US" sz="1200" dirty="0"/>
                     </a:p>
                     <a:p>
                       <a:pPr algn="l" indent="0" marL="0">
                         <a:buNone/>
                       </a:pPr>
                       <a:r>
-                        <a:rPr lang="en-US" sz="770" dirty="0">
+                        <a:rPr lang="en-US" sz="800" dirty="0">
                           <a:solidFill>
                             <a:srgbClr val="CFE0EC"/>
                           </a:solidFill>
@@ -7409,7 +7442,7 @@
                         </a:rPr>
                         <a:t>規則</a:t>
                       </a:r>
-                      <a:endParaRPr lang="en-US" sz="1020" dirty="0"/>
+                      <a:endParaRPr lang="en-US" sz="1200" dirty="0"/>
                     </a:p>
                   </a:txBody>
                   <a:tcPr marL="63500" marR="63500" marT="38100" marB="38100" anchor="ctr">
@@ -7463,7 +7496,7 @@
                         <a:buNone/>
                       </a:pPr>
                       <a:r>
-                        <a:rPr lang="en-US" sz="890" b="1" dirty="0">
+                        <a:rPr lang="en-US" sz="950" b="1" dirty="0">
                           <a:solidFill>
                             <a:srgbClr val="FFFFFF"/>
                           </a:solidFill>
@@ -7473,14 +7506,14 @@
                         </a:rPr>
                         <a:t>Nguyên văn (tiếng Anh)</a:t>
                       </a:r>
-                      <a:endParaRPr lang="en-US" sz="1020" dirty="0"/>
+                      <a:endParaRPr lang="en-US" sz="1200" dirty="0"/>
                     </a:p>
                     <a:p>
                       <a:pPr algn="l" indent="0" marL="0">
                         <a:buNone/>
                       </a:pPr>
                       <a:r>
-                        <a:rPr lang="en-US" sz="770" dirty="0">
+                        <a:rPr lang="en-US" sz="800" dirty="0">
                           <a:solidFill>
                             <a:srgbClr val="CFE0EC"/>
                           </a:solidFill>
@@ -7490,7 +7523,7 @@
                         </a:rPr>
                         <a:t>原文</a:t>
                       </a:r>
-                      <a:endParaRPr lang="en-US" sz="1020" dirty="0"/>
+                      <a:endParaRPr lang="en-US" sz="1200" dirty="0"/>
                     </a:p>
                   </a:txBody>
                   <a:tcPr marL="63500" marR="63500" marT="38100" marB="38100" anchor="ctr">
@@ -7544,7 +7577,7 @@
                         <a:buNone/>
                       </a:pPr>
                       <a:r>
-                        <a:rPr lang="en-US" sz="890" b="1" dirty="0">
+                        <a:rPr lang="en-US" sz="950" b="1" dirty="0">
                           <a:solidFill>
                             <a:srgbClr val="FFFFFF"/>
                           </a:solidFill>
@@ -7554,14 +7587,14 @@
                         </a:rPr>
                         <a:t>Vì sao</a:t>
                       </a:r>
-                      <a:endParaRPr lang="en-US" sz="1020" dirty="0"/>
+                      <a:endParaRPr lang="en-US" sz="1200" dirty="0"/>
                     </a:p>
                     <a:p>
                       <a:pPr algn="l" indent="0" marL="0">
                         <a:buNone/>
                       </a:pPr>
                       <a:r>
-                        <a:rPr lang="en-US" sz="770" dirty="0">
+                        <a:rPr lang="en-US" sz="800" dirty="0">
                           <a:solidFill>
                             <a:srgbClr val="CFE0EC"/>
                           </a:solidFill>
@@ -7571,7 +7604,7 @@
                         </a:rPr>
                         <a:t>為什麼</a:t>
                       </a:r>
-                      <a:endParaRPr lang="en-US" sz="1020" dirty="0"/>
+                      <a:endParaRPr lang="en-US" sz="1200" dirty="0"/>
                     </a:p>
                   </a:txBody>
                   <a:tcPr marL="63500" marR="63500" marT="38100" marB="38100" anchor="ctr">
@@ -7617,7 +7650,7 @@
                   </a:tcPr>
                 </a:tc>
               </a:tr>
-              <a:tr h="326858">
+              <a:tr h="274320">
                 <a:tc>
                   <a:txBody>
                     <a:bodyPr/>
@@ -7627,7 +7660,7 @@
                         <a:buNone/>
                       </a:pPr>
                       <a:r>
-                        <a:rPr lang="en-US" sz="890" b="1" dirty="0">
+                        <a:rPr lang="en-US" sz="950" b="1" dirty="0">
                           <a:solidFill>
                             <a:srgbClr val="0B1F3A"/>
                           </a:solidFill>
@@ -7637,14 +7670,14 @@
                         </a:rPr>
                         <a:t>Có ≥ 1 điểm lidar hoặc radar là phải gán</a:t>
                       </a:r>
-                      <a:endParaRPr lang="en-US" sz="1020" dirty="0"/>
+                      <a:endParaRPr lang="en-US" sz="1200" dirty="0"/>
                     </a:p>
                     <a:p>
                       <a:pPr algn="l" indent="0" marL="0">
                         <a:buNone/>
                       </a:pPr>
                       <a:r>
-                        <a:rPr lang="en-US" sz="770" dirty="0">
+                        <a:rPr lang="en-US" sz="800" dirty="0">
                           <a:solidFill>
                             <a:srgbClr val="5F7183"/>
                           </a:solidFill>
@@ -7654,7 +7687,7 @@
                         </a:rPr>
                         <a:t>有 1 個光達或雷達點就要標</a:t>
                       </a:r>
-                      <a:endParaRPr lang="en-US" sz="1020" dirty="0"/>
+                      <a:endParaRPr lang="en-US" sz="1200" dirty="0"/>
                     </a:p>
                   </a:txBody>
                   <a:tcPr marL="63500" marR="63500" marT="38100" marB="38100" anchor="ctr">
@@ -7705,7 +7738,7 @@
                         <a:buNone/>
                       </a:pPr>
                       <a:r>
-                        <a:rPr lang="en-US" sz="890" dirty="0">
+                        <a:rPr lang="en-US" sz="950" dirty="0">
                           <a:solidFill>
                             <a:srgbClr val="1A2733"/>
                           </a:solidFill>
@@ -7715,7 +7748,7 @@
                         </a:rPr>
                         <a:t>Label any target object containing at least 1 LIDAR or RADAR point</a:t>
                       </a:r>
-                      <a:endParaRPr lang="en-US" sz="1020" dirty="0"/>
+                      <a:endParaRPr lang="en-US" sz="1200" dirty="0"/>
                     </a:p>
                   </a:txBody>
                   <a:tcPr marL="63500" marR="63500" marT="38100" marB="38100" anchor="ctr">
@@ -7766,7 +7799,7 @@
                         <a:buNone/>
                       </a:pPr>
                       <a:r>
-                        <a:rPr lang="en-US" sz="890" dirty="0">
+                        <a:rPr lang="en-US" sz="950" dirty="0">
                           <a:solidFill>
                             <a:srgbClr val="1A2733"/>
                           </a:solidFill>
@@ -7776,14 +7809,14 @@
                         </a:rPr>
                         <a:t>Cảm biến thấy được thì mô hình phải học</a:t>
                       </a:r>
-                      <a:endParaRPr lang="en-US" sz="1020" dirty="0"/>
+                      <a:endParaRPr lang="en-US" sz="1200" dirty="0"/>
                     </a:p>
                     <a:p>
                       <a:pPr algn="l" indent="0" marL="0">
                         <a:buNone/>
                       </a:pPr>
                       <a:r>
-                        <a:rPr lang="en-US" sz="770" dirty="0">
+                        <a:rPr lang="en-US" sz="800" dirty="0">
                           <a:solidFill>
                             <a:srgbClr val="5F7183"/>
                           </a:solidFill>
@@ -7793,7 +7826,7 @@
                         </a:rPr>
                         <a:t>感測器看得到，模型就該學</a:t>
                       </a:r>
-                      <a:endParaRPr lang="en-US" sz="1020" dirty="0"/>
+                      <a:endParaRPr lang="en-US" sz="1200" dirty="0"/>
                     </a:p>
                   </a:txBody>
                   <a:tcPr marL="63500" marR="63500" marT="38100" marB="38100" anchor="ctr">
@@ -7836,7 +7869,7 @@
                   </a:tcPr>
                 </a:tc>
               </a:tr>
-              <a:tr h="326858">
+              <a:tr h="274320">
                 <a:tc>
                   <a:txBody>
                     <a:bodyPr/>
@@ -7846,7 +7879,7 @@
                         <a:buNone/>
                       </a:pPr>
                       <a:r>
-                        <a:rPr lang="en-US" sz="890" b="1" dirty="0">
+                        <a:rPr lang="en-US" sz="950" b="1" dirty="0">
                           <a:solidFill>
                             <a:srgbClr val="0B1F3A"/>
                           </a:solidFill>
@@ -7856,14 +7889,14 @@
                         </a:rPr>
                         <a:t>Khung phải rất sát</a:t>
                       </a:r>
-                      <a:endParaRPr lang="en-US" sz="1020" dirty="0"/>
+                      <a:endParaRPr lang="en-US" sz="1200" dirty="0"/>
                     </a:p>
                     <a:p>
                       <a:pPr algn="l" indent="0" marL="0">
                         <a:buNone/>
                       </a:pPr>
                       <a:r>
-                        <a:rPr lang="en-US" sz="770" dirty="0">
+                        <a:rPr lang="en-US" sz="800" dirty="0">
                           <a:solidFill>
                             <a:srgbClr val="5F7183"/>
                           </a:solidFill>
@@ -7873,7 +7906,7 @@
                         </a:rPr>
                         <a:t>框要很貼</a:t>
                       </a:r>
-                      <a:endParaRPr lang="en-US" sz="1020" dirty="0"/>
+                      <a:endParaRPr lang="en-US" sz="1200" dirty="0"/>
                     </a:p>
                   </a:txBody>
                   <a:tcPr marL="63500" marR="63500" marT="38100" marB="38100" anchor="ctr">
@@ -7924,7 +7957,7 @@
                         <a:buNone/>
                       </a:pPr>
                       <a:r>
-                        <a:rPr lang="en-US" sz="890" dirty="0">
+                        <a:rPr lang="en-US" sz="950" dirty="0">
                           <a:solidFill>
                             <a:srgbClr val="1A2733"/>
                           </a:solidFill>
@@ -7934,7 +7967,7 @@
                         </a:rPr>
                         <a:t>Cuboids must be very tight.</a:t>
                       </a:r>
-                      <a:endParaRPr lang="en-US" sz="1020" dirty="0"/>
+                      <a:endParaRPr lang="en-US" sz="1200" dirty="0"/>
                     </a:p>
                   </a:txBody>
                   <a:tcPr marL="63500" marR="63500" marT="38100" marB="38100" anchor="ctr">
@@ -7985,7 +8018,7 @@
                         <a:buNone/>
                       </a:pPr>
                       <a:r>
-                        <a:rPr lang="en-US" sz="890" dirty="0">
+                        <a:rPr lang="en-US" sz="950" dirty="0">
                           <a:solidFill>
                             <a:srgbClr val="1A2733"/>
                           </a:solidFill>
@@ -7995,14 +8028,14 @@
                         </a:rPr>
                         <a:t>Khung rộng → sai vị trí, sai khoảng cách</a:t>
                       </a:r>
-                      <a:endParaRPr lang="en-US" sz="1020" dirty="0"/>
+                      <a:endParaRPr lang="en-US" sz="1200" dirty="0"/>
                     </a:p>
                     <a:p>
                       <a:pPr algn="l" indent="0" marL="0">
                         <a:buNone/>
                       </a:pPr>
                       <a:r>
-                        <a:rPr lang="en-US" sz="770" dirty="0">
+                        <a:rPr lang="en-US" sz="800" dirty="0">
                           <a:solidFill>
                             <a:srgbClr val="5F7183"/>
                           </a:solidFill>
@@ -8012,7 +8045,7 @@
                         </a:rPr>
                         <a:t>框太鬆→位置、距離都不準</a:t>
                       </a:r>
-                      <a:endParaRPr lang="en-US" sz="1020" dirty="0"/>
+                      <a:endParaRPr lang="en-US" sz="1200" dirty="0"/>
                     </a:p>
                   </a:txBody>
                   <a:tcPr marL="63500" marR="63500" marT="38100" marB="38100" anchor="ctr">
@@ -8055,7 +8088,7 @@
                   </a:tcPr>
                 </a:tc>
               </a:tr>
-              <a:tr h="326858">
+              <a:tr h="274320">
                 <a:tc>
                   <a:txBody>
                     <a:bodyPr/>
@@ -8065,7 +8098,7 @@
                         <a:buNone/>
                       </a:pPr>
                       <a:r>
-                        <a:rPr lang="en-US" sz="890" b="1" dirty="0">
+                        <a:rPr lang="en-US" sz="950" b="1" dirty="0">
                           <a:solidFill>
                             <a:srgbClr val="0B1F3A"/>
                           </a:solidFill>
@@ -8075,14 +8108,14 @@
                         </a:rPr>
                         <a:t>Tay chân phải nằm trong khung</a:t>
                       </a:r>
-                      <a:endParaRPr lang="en-US" sz="1020" dirty="0"/>
+                      <a:endParaRPr lang="en-US" sz="1200" dirty="0"/>
                     </a:p>
                     <a:p>
                       <a:pPr algn="l" indent="0" marL="0">
                         <a:buNone/>
                       </a:pPr>
                       <a:r>
-                        <a:rPr lang="en-US" sz="770" dirty="0">
+                        <a:rPr lang="en-US" sz="800" dirty="0">
                           <a:solidFill>
                             <a:srgbClr val="5F7183"/>
                           </a:solidFill>
@@ -8092,7 +8125,7 @@
                         </a:rPr>
                         <a:t>手腳要包進去</a:t>
                       </a:r>
-                      <a:endParaRPr lang="en-US" sz="1020" dirty="0"/>
+                      <a:endParaRPr lang="en-US" sz="1200" dirty="0"/>
                     </a:p>
                   </a:txBody>
                   <a:tcPr marL="63500" marR="63500" marT="38100" marB="38100" anchor="ctr">
@@ -8143,7 +8176,7 @@
                         <a:buNone/>
                       </a:pPr>
                       <a:r>
-                        <a:rPr lang="en-US" sz="890" dirty="0">
+                        <a:rPr lang="en-US" sz="950" dirty="0">
                           <a:solidFill>
                             <a:srgbClr val="1A2733"/>
                           </a:solidFill>
@@ -8153,7 +8186,7 @@
                         </a:rPr>
                         <a:t>…the bounding box should include the extremities.</a:t>
                       </a:r>
-                      <a:endParaRPr lang="en-US" sz="1020" dirty="0"/>
+                      <a:endParaRPr lang="en-US" sz="1200" dirty="0"/>
                     </a:p>
                   </a:txBody>
                   <a:tcPr marL="63500" marR="63500" marT="38100" marB="38100" anchor="ctr">
@@ -8204,7 +8237,7 @@
                         <a:buNone/>
                       </a:pPr>
                       <a:r>
-                        <a:rPr lang="en-US" sz="890" dirty="0">
+                        <a:rPr lang="en-US" sz="950" dirty="0">
                           <a:solidFill>
                             <a:srgbClr val="1A2733"/>
                           </a:solidFill>
@@ -8214,14 +8247,14 @@
                         </a:rPr>
                         <a:t>Tay giơ ra cũng có thể bị đụng</a:t>
                       </a:r>
-                      <a:endParaRPr lang="en-US" sz="1020" dirty="0"/>
+                      <a:endParaRPr lang="en-US" sz="1200" dirty="0"/>
                     </a:p>
                     <a:p>
                       <a:pPr algn="l" indent="0" marL="0">
                         <a:buNone/>
                       </a:pPr>
                       <a:r>
-                        <a:rPr lang="en-US" sz="770" dirty="0">
+                        <a:rPr lang="en-US" sz="800" dirty="0">
                           <a:solidFill>
                             <a:srgbClr val="5F7183"/>
                           </a:solidFill>
@@ -8231,7 +8264,7 @@
                         </a:rPr>
                         <a:t>伸出去的手也會被撞到</a:t>
                       </a:r>
-                      <a:endParaRPr lang="en-US" sz="1020" dirty="0"/>
+                      <a:endParaRPr lang="en-US" sz="1200" dirty="0"/>
                     </a:p>
                   </a:txBody>
                   <a:tcPr marL="63500" marR="63500" marT="38100" marB="38100" anchor="ctr">
@@ -8274,7 +8307,7 @@
                   </a:tcPr>
                 </a:tc>
               </a:tr>
-              <a:tr h="326858">
+              <a:tr h="274320">
                 <a:tc>
                   <a:txBody>
                     <a:bodyPr/>
@@ -8284,7 +8317,7 @@
                         <a:buNone/>
                       </a:pPr>
                       <a:r>
-                        <a:rPr lang="en-US" sz="890" b="1" dirty="0">
+                        <a:rPr lang="en-US" sz="950" b="1" dirty="0">
                           <a:solidFill>
                             <a:srgbClr val="0B1F3A"/>
                           </a:solidFill>
@@ -8294,14 +8327,14 @@
                         </a:rPr>
                         <a:t>Có người lái: người lái chung khung với xe</a:t>
                       </a:r>
-                      <a:endParaRPr lang="en-US" sz="1020" dirty="0"/>
+                      <a:endParaRPr lang="en-US" sz="1200" dirty="0"/>
                     </a:p>
                     <a:p>
                       <a:pPr algn="l" indent="0" marL="0">
                         <a:buNone/>
                       </a:pPr>
                       <a:r>
-                        <a:rPr lang="en-US" sz="770" dirty="0">
+                        <a:rPr lang="en-US" sz="800" dirty="0">
                           <a:solidFill>
                             <a:srgbClr val="5F7183"/>
                           </a:solidFill>
@@ -8311,7 +8344,7 @@
                         </a:rPr>
                         <a:t>有人騎：騎士和車同一個框</a:t>
                       </a:r>
-                      <a:endParaRPr lang="en-US" sz="1020" dirty="0"/>
+                      <a:endParaRPr lang="en-US" sz="1200" dirty="0"/>
                     </a:p>
                   </a:txBody>
                   <a:tcPr marL="63500" marR="63500" marT="38100" marB="38100" anchor="ctr">
@@ -8362,7 +8395,7 @@
                         <a:buNone/>
                       </a:pPr>
                       <a:r>
-                        <a:rPr lang="en-US" sz="890" dirty="0">
+                        <a:rPr lang="en-US" sz="950" dirty="0">
                           <a:solidFill>
                             <a:srgbClr val="1A2733"/>
                           </a:solidFill>
@@ -8372,7 +8405,7 @@
                         </a:rPr>
                         <a:t>If there is a rider, include the rider in the box.</a:t>
                       </a:r>
-                      <a:endParaRPr lang="en-US" sz="1020" dirty="0"/>
+                      <a:endParaRPr lang="en-US" sz="1200" dirty="0"/>
                     </a:p>
                   </a:txBody>
                   <a:tcPr marL="63500" marR="63500" marT="38100" marB="38100" anchor="ctr">
@@ -8423,7 +8456,7 @@
                         <a:buNone/>
                       </a:pPr>
                       <a:r>
-                        <a:rPr lang="en-US" sz="890" dirty="0">
+                        <a:rPr lang="en-US" sz="950" dirty="0">
                           <a:solidFill>
                             <a:srgbClr val="1A2733"/>
                           </a:solidFill>
@@ -8433,14 +8466,14 @@
                         </a:rPr>
                         <a:t>Người và xe đi cùng nhau</a:t>
                       </a:r>
-                      <a:endParaRPr lang="en-US" sz="1020" dirty="0"/>
+                      <a:endParaRPr lang="en-US" sz="1200" dirty="0"/>
                     </a:p>
                     <a:p>
                       <a:pPr algn="l" indent="0" marL="0">
                         <a:buNone/>
                       </a:pPr>
                       <a:r>
-                        <a:rPr lang="en-US" sz="770" dirty="0">
+                        <a:rPr lang="en-US" sz="800" dirty="0">
                           <a:solidFill>
                             <a:srgbClr val="5F7183"/>
                           </a:solidFill>
@@ -8450,7 +8483,7 @@
                         </a:rPr>
                         <a:t>人和車一起動</a:t>
                       </a:r>
-                      <a:endParaRPr lang="en-US" sz="1020" dirty="0"/>
+                      <a:endParaRPr lang="en-US" sz="1200" dirty="0"/>
                     </a:p>
                   </a:txBody>
                   <a:tcPr marL="63500" marR="63500" marT="38100" marB="38100" anchor="ctr">
@@ -8493,7 +8526,7 @@
                   </a:tcPr>
                 </a:tc>
               </a:tr>
-              <a:tr h="326858">
+              <a:tr h="274320">
                 <a:tc>
                   <a:txBody>
                     <a:bodyPr/>
@@ -8503,7 +8536,7 @@
                         <a:buNone/>
                       </a:pPr>
                       <a:r>
-                        <a:rPr lang="en-US" sz="890" b="1" dirty="0">
+                        <a:rPr lang="en-US" sz="950" b="1" dirty="0">
                           <a:solidFill>
                             <a:srgbClr val="0B1F3A"/>
                           </a:solidFill>
@@ -8513,14 +8546,14 @@
                         </a:rPr>
                         <a:t>Người đứng bên cạnh xe: khoanh riêng</a:t>
                       </a:r>
-                      <a:endParaRPr lang="en-US" sz="1020" dirty="0"/>
+                      <a:endParaRPr lang="en-US" sz="1200" dirty="0"/>
                     </a:p>
                     <a:p>
                       <a:pPr algn="l" indent="0" marL="0">
                         <a:buNone/>
                       </a:pPr>
                       <a:r>
-                        <a:rPr lang="en-US" sz="770" dirty="0">
+                        <a:rPr lang="en-US" sz="800" dirty="0">
                           <a:solidFill>
                             <a:srgbClr val="5F7183"/>
                           </a:solidFill>
@@ -8530,7 +8563,7 @@
                         </a:rPr>
                         <a:t>旁邊站著的人：另外框</a:t>
                       </a:r>
-                      <a:endParaRPr lang="en-US" sz="1020" dirty="0"/>
+                      <a:endParaRPr lang="en-US" sz="1200" dirty="0"/>
                     </a:p>
                   </a:txBody>
                   <a:tcPr marL="63500" marR="63500" marT="38100" marB="38100" anchor="ctr">
@@ -8581,7 +8614,7 @@
                         <a:buNone/>
                       </a:pPr>
                       <a:r>
-                        <a:rPr lang="en-US" sz="890" dirty="0">
+                        <a:rPr lang="en-US" sz="950" dirty="0">
                           <a:solidFill>
                             <a:srgbClr val="1A2733"/>
                           </a:solidFill>
@@ -8591,7 +8624,7 @@
                         </a:rPr>
                         <a:t>…standing next to the motorcycle, do NOT include…</a:t>
                       </a:r>
-                      <a:endParaRPr lang="en-US" sz="1020" dirty="0"/>
+                      <a:endParaRPr lang="en-US" sz="1200" dirty="0"/>
                     </a:p>
                   </a:txBody>
                   <a:tcPr marL="63500" marR="63500" marT="38100" marB="38100" anchor="ctr">
@@ -8642,7 +8675,7 @@
                         <a:buNone/>
                       </a:pPr>
                       <a:r>
-                        <a:rPr lang="en-US" sz="890" dirty="0">
+                        <a:rPr lang="en-US" sz="950" dirty="0">
                           <a:solidFill>
                             <a:srgbClr val="1A2733"/>
                           </a:solidFill>
@@ -8652,14 +8685,14 @@
                         </a:rPr>
                         <a:t>Người đó có thể đi chỗ khác</a:t>
                       </a:r>
-                      <a:endParaRPr lang="en-US" sz="1020" dirty="0"/>
+                      <a:endParaRPr lang="en-US" sz="1200" dirty="0"/>
                     </a:p>
                     <a:p>
                       <a:pPr algn="l" indent="0" marL="0">
                         <a:buNone/>
                       </a:pPr>
                       <a:r>
-                        <a:rPr lang="en-US" sz="770" dirty="0">
+                        <a:rPr lang="en-US" sz="800" dirty="0">
                           <a:solidFill>
                             <a:srgbClr val="5F7183"/>
                           </a:solidFill>
@@ -8669,7 +8702,7 @@
                         </a:rPr>
                         <a:t>那個人可能自己走開</a:t>
                       </a:r>
-                      <a:endParaRPr lang="en-US" sz="1020" dirty="0"/>
+                      <a:endParaRPr lang="en-US" sz="1200" dirty="0"/>
                     </a:p>
                   </a:txBody>
                   <a:tcPr marL="63500" marR="63500" marT="38100" marB="38100" anchor="ctr">
@@ -8712,7 +8745,7 @@
                   </a:tcPr>
                 </a:tc>
               </a:tr>
-              <a:tr h="326858">
+              <a:tr h="274320">
                 <a:tc>
                   <a:txBody>
                     <a:bodyPr/>
@@ -8722,7 +8755,7 @@
                         <a:buNone/>
                       </a:pPr>
                       <a:r>
-                        <a:rPr lang="en-US" sz="890" b="1" dirty="0">
+                        <a:rPr lang="en-US" sz="950" b="1" dirty="0">
                           <a:solidFill>
                             <a:srgbClr val="0B1F3A"/>
                           </a:solidFill>
@@ -8732,14 +8765,14 @@
                         </a:rPr>
                         <a:t>Độ thấy được: 4 mức</a:t>
                       </a:r>
-                      <a:endParaRPr lang="en-US" sz="1020" dirty="0"/>
+                      <a:endParaRPr lang="en-US" sz="1200" dirty="0"/>
                     </a:p>
                     <a:p>
                       <a:pPr algn="l" indent="0" marL="0">
                         <a:buNone/>
                       </a:pPr>
                       <a:r>
-                        <a:rPr lang="en-US" sz="770" dirty="0">
+                        <a:rPr lang="en-US" sz="800" dirty="0">
                           <a:solidFill>
                             <a:srgbClr val="5F7183"/>
                           </a:solidFill>
@@ -8749,7 +8782,7 @@
                         </a:rPr>
                         <a:t>可見度分四級</a:t>
                       </a:r>
-                      <a:endParaRPr lang="en-US" sz="1020" dirty="0"/>
+                      <a:endParaRPr lang="en-US" sz="1200" dirty="0"/>
                     </a:p>
                   </a:txBody>
                   <a:tcPr marL="63500" marR="63500" marT="38100" marB="38100" anchor="ctr">
@@ -8800,7 +8833,7 @@
                         <a:buNone/>
                       </a:pPr>
                       <a:r>
-                        <a:rPr lang="en-US" sz="890" dirty="0">
+                        <a:rPr lang="en-US" sz="950" dirty="0">
                           <a:solidFill>
                             <a:srgbClr val="1A2733"/>
                           </a:solidFill>
@@ -8810,7 +8843,7 @@
                         </a:rPr>
                         <a:t>0–40%, 41–60%, 61–80%, 81–100%</a:t>
                       </a:r>
-                      <a:endParaRPr lang="en-US" sz="1020" dirty="0"/>
+                      <a:endParaRPr lang="en-US" sz="1200" dirty="0"/>
                     </a:p>
                   </a:txBody>
                   <a:tcPr marL="63500" marR="63500" marT="38100" marB="38100" anchor="ctr">
@@ -8861,7 +8894,7 @@
                         <a:buNone/>
                       </a:pPr>
                       <a:r>
-                        <a:rPr lang="en-US" sz="890" dirty="0">
+                        <a:rPr lang="en-US" sz="950" dirty="0">
                           <a:solidFill>
                             <a:srgbClr val="1A2733"/>
                           </a:solidFill>
@@ -8871,14 +8904,14 @@
                         </a:rPr>
                         <a:t>Biết vật nào bị che nhiều</a:t>
                       </a:r>
-                      <a:endParaRPr lang="en-US" sz="1020" dirty="0"/>
+                      <a:endParaRPr lang="en-US" sz="1200" dirty="0"/>
                     </a:p>
                     <a:p>
                       <a:pPr algn="l" indent="0" marL="0">
                         <a:buNone/>
                       </a:pPr>
                       <a:r>
-                        <a:rPr lang="en-US" sz="770" dirty="0">
+                        <a:rPr lang="en-US" sz="800" dirty="0">
                           <a:solidFill>
                             <a:srgbClr val="5F7183"/>
                           </a:solidFill>
@@ -8888,7 +8921,7 @@
                         </a:rPr>
                         <a:t>知道哪些被擋得多</a:t>
                       </a:r>
-                      <a:endParaRPr lang="en-US" sz="1020" dirty="0"/>
+                      <a:endParaRPr lang="en-US" sz="1200" dirty="0"/>
                     </a:p>
                   </a:txBody>
                   <a:tcPr marL="63500" marR="63500" marT="38100" marB="38100" anchor="ctr">
@@ -8937,14 +8970,34 @@
       </p:graphicFrame>
       <p:sp>
         <p:nvSpPr>
-          <p:cNvPr id="4" name="Text 1"/>
+          <p:cNvPr id="4" name="Shape 1"/>
+          <p:cNvSpPr/>
+          <p:nvPr/>
+        </p:nvSpPr>
+        <p:spPr>
+          <a:xfrm>
+            <a:off x="539496" y="4362293"/>
+            <a:ext cx="219456" cy="219456"/>
+          </a:xfrm>
+          <a:prstGeom prst="ellipse">
+            <a:avLst/>
+          </a:prstGeom>
+          <a:solidFill>
+            <a:srgbClr val="D9463E"/>
+          </a:solidFill>
+          <a:ln/>
+        </p:spPr>
+      </p:sp>
+      <p:sp>
+        <p:nvSpPr>
+          <p:cNvPr id="5" name="Text 2"/>
           <p:cNvSpPr txBox="1"/>
           <p:nvPr/>
         </p:nvSpPr>
         <p:spPr>
           <a:xfrm>
-            <a:off x="1108865" y="4240034"/>
-            <a:ext cx="6926270" cy="389116"/>
+            <a:off x="539496" y="4389725"/>
+            <a:ext cx="219456" cy="164592"/>
           </a:xfrm>
           <a:prstGeom prst="rect">
             <a:avLst/>
@@ -8953,60 +9006,134 @@
           <a:ln/>
         </p:spPr>
         <p:txBody>
-          <a:bodyPr wrap="square" lIns="0" tIns="0" rIns="0" bIns="0" rtlCol="0" anchor="t"/>
+          <a:bodyPr wrap="square" lIns="0" tIns="0" rIns="0" bIns="0" rtlCol="0" anchor="ctr"/>
           <a:lstStyle/>
           <a:p>
-            <a:pPr indent="0" marL="0">
-              <a:lnSpc>
-                <a:spcPct val="116000"/>
-              </a:lnSpc>
-              <a:buNone/>
-            </a:pPr>
-            <a:r>
-              <a:rPr lang="en-US" sz="1020" b="1" dirty="0">
-                <a:solidFill>
-                  <a:srgbClr val="007F72"/>
+            <a:pPr algn="ctr" indent="0" marL="0">
+              <a:buNone/>
+            </a:pPr>
+            <a:r>
+              <a:rPr lang="en-US" sz="750" b="1" dirty="0">
+                <a:solidFill>
+                  <a:srgbClr val="FFFFFF"/>
                 </a:solidFill>
                 <a:latin typeface="Arial" pitchFamily="34" charset="0"/>
                 <a:ea typeface="Arial" pitchFamily="34" charset="-122"/>
                 <a:cs typeface="Arial" pitchFamily="34" charset="-120"/>
               </a:rPr>
-              <a:t>nuScenes gán khung 3D; hôm nay chúng ta gán khung 2D trên ảnh, quy tắc giống nhau.</a:t>
-            </a:r>
-            <a:endParaRPr lang="en-US" sz="1020" dirty="0"/>
-          </a:p>
+              <a:t>▶</a:t>
+            </a:r>
+            <a:endParaRPr lang="en-US" sz="750" dirty="0"/>
+          </a:p>
+        </p:txBody>
+      </p:sp>
+      <p:sp>
+        <p:nvSpPr>
+          <p:cNvPr id="6" name="Text 3"/>
+          <p:cNvSpPr txBox="1"/>
+          <p:nvPr/>
+        </p:nvSpPr>
+        <p:spPr>
+          <a:xfrm>
+            <a:off x="832104" y="4334861"/>
+            <a:ext cx="7808976" cy="274320"/>
+          </a:xfrm>
+          <a:prstGeom prst="rect">
+            <a:avLst/>
+          </a:prstGeom>
+          <a:noFill/>
+          <a:ln/>
+        </p:spPr>
+        <p:txBody>
+          <a:bodyPr wrap="square" lIns="0" tIns="0" rIns="0" bIns="0" rtlCol="0" anchor="ctr"/>
+          <a:lstStyle/>
           <a:p>
             <a:pPr indent="0" marL="0">
               <a:lnSpc>
-                <a:spcPct val="116000"/>
+                <a:spcPct val="100000"/>
               </a:lnSpc>
               <a:buNone/>
             </a:pPr>
             <a:r>
-              <a:rPr lang="en-US" sz="940" dirty="0">
-                <a:solidFill>
-                  <a:srgbClr val="007F72"/>
+              <a:rPr lang="en-US" sz="900" b="1" u="sng" dirty="0">
+                <a:solidFill>
+                  <a:srgbClr val="0B1F3A"/>
+                </a:solidFill>
+                <a:latin typeface="Arial" pitchFamily="34" charset="0"/>
+                <a:ea typeface="Arial" pitchFamily="34" charset="-122"/>
+                <a:cs typeface="Arial" pitchFamily="34" charset="-120"/>
+                <a:hlinkClick r:id="rId1" invalidUrl="" action="" tgtFrame="" tooltip="" history="1" highlightClick="0" endSnd="0">
+                  <a:extLst>
+                    <a:ext uri="{A12FA001-AC4F-418D-AE19-62706E023703}">
+                      <ahyp:hlinkClr xmlns:ahyp="http://schemas.microsoft.com/office/drawing/2018/hyperlinkcolor" val="tx"/>
+                    </a:ext>
+                  </a:extLst>
+                </a:hlinkClick>
+              </a:rPr>
+              <a:t>Video: vẽ khung bằng CVAT · </a:t>
+            </a:r>
+            <a:pPr indent="0" marL="0">
+              <a:lnSpc>
+                <a:spcPct val="100000"/>
+              </a:lnSpc>
+              <a:buNone/>
+            </a:pPr>
+            <a:r>
+              <a:rPr lang="en-US" sz="900" b="1" u="sng" dirty="0">
+                <a:solidFill>
+                  <a:srgbClr val="0B1F3A"/>
                 </a:solidFill>
                 <a:latin typeface="微軟正黑體" pitchFamily="34" charset="0"/>
                 <a:ea typeface="微軟正黑體" pitchFamily="34" charset="-122"/>
                 <a:cs typeface="微軟正黑體" pitchFamily="34" charset="-120"/>
-              </a:rPr>
-              <a:t>nuScenes 標的是立體框；今天我們在照片上標平面框，規則一樣。</a:t>
-            </a:r>
-            <a:endParaRPr lang="en-US" sz="1020" dirty="0"/>
+                <a:hlinkClick r:id="rId1" invalidUrl="" action="" tgtFrame="" tooltip="" history="1" highlightClick="0" endSnd="0">
+                  <a:extLst>
+                    <a:ext uri="{A12FA001-AC4F-418D-AE19-62706E023703}">
+                      <ahyp:hlinkClr xmlns:ahyp="http://schemas.microsoft.com/office/drawing/2018/hyperlinkcolor" val="tx"/>
+                    </a:ext>
+                  </a:extLst>
+                </a:hlinkClick>
+              </a:rPr>
+              <a:t>影片：用 CVAT 畫框（標註工具教學）　0:16–2:47　</a:t>
+            </a:r>
+            <a:pPr indent="0" marL="0">
+              <a:lnSpc>
+                <a:spcPct val="100000"/>
+              </a:lnSpc>
+              <a:buNone/>
+            </a:pPr>
+            <a:r>
+              <a:rPr lang="en-US" sz="900" u="sng" dirty="0">
+                <a:solidFill>
+                  <a:srgbClr val="1F6FBF"/>
+                </a:solidFill>
+                <a:latin typeface="Arial" pitchFamily="34" charset="0"/>
+                <a:ea typeface="Arial" pitchFamily="34" charset="-122"/>
+                <a:cs typeface="Arial" pitchFamily="34" charset="-120"/>
+                <a:hlinkClick r:id="rId1" invalidUrl="" action="" tgtFrame="" tooltip="" history="1" highlightClick="0" endSnd="0">
+                  <a:extLst>
+                    <a:ext uri="{A12FA001-AC4F-418D-AE19-62706E023703}">
+                      <ahyp:hlinkClr xmlns:ahyp="http://schemas.microsoft.com/office/drawing/2018/hyperlinkcolor" val="tx"/>
+                    </a:ext>
+                  </a:extLst>
+                </a:hlinkClick>
+              </a:rPr>
+              <a:t>youtu.be/TDae8RkGbKk?t=16</a:t>
+            </a:r>
+            <a:endParaRPr lang="en-US" sz="900" dirty="0"/>
           </a:p>
         </p:txBody>
       </p:sp>
       <p:pic>
         <p:nvPicPr>
-          <p:cNvPr id="6" name="Image 0" descr="/Users/tsengchenghsun/Class/carClass/Claude outputs/第八週(10-29)/src/logo.png">    </p:cNvPr>
+          <p:cNvPr id="8" name="Image 0" descr="/Users/tsengchenghsun/Class/carClass/Claude outputs/第八週(10-29)/src/logo.png">    </p:cNvPr>
           <p:cNvPicPr>
             <a:picLocks noChangeAspect="1"/>
           </p:cNvPicPr>
           <p:nvPr/>
         </p:nvPicPr>
         <p:blipFill>
-          <a:blip r:embed="rId1"/>
+          <a:blip r:embed="rId2"/>
           <a:stretch>
             <a:fillRect/>
           </a:stretch>
@@ -9023,14 +9150,14 @@
       </p:pic>
       <p:sp>
         <p:nvSpPr>
-          <p:cNvPr id="7" name="Text 2"/>
+          <p:cNvPr id="9" name="Text 4"/>
           <p:cNvSpPr txBox="1"/>
           <p:nvPr/>
         </p:nvSpPr>
         <p:spPr>
           <a:xfrm>
-            <a:off x="774225" y="108953"/>
-            <a:ext cx="700409" cy="217905"/>
+            <a:off x="109728" y="128016"/>
+            <a:ext cx="822960" cy="256032"/>
           </a:xfrm>
           <a:prstGeom prst="rect">
             <a:avLst/>
@@ -9046,7 +9173,7 @@
               <a:buNone/>
             </a:pPr>
             <a:r>
-              <a:rPr lang="en-US" sz="770" dirty="0">
+              <a:rPr lang="en-US" sz="900" dirty="0">
                 <a:solidFill>
                   <a:srgbClr val="5F7183"/>
                 </a:solidFill>
@@ -9056,20 +9183,20 @@
               </a:rPr>
               <a:t>4 / 11</a:t>
             </a:r>
-            <a:endParaRPr lang="en-US" sz="770" dirty="0"/>
+            <a:endParaRPr lang="en-US" sz="900" dirty="0"/>
           </a:p>
         </p:txBody>
       </p:sp>
       <p:sp>
         <p:nvSpPr>
-          <p:cNvPr id="8" name="Text 3"/>
+          <p:cNvPr id="10" name="Text 5"/>
           <p:cNvSpPr txBox="1"/>
           <p:nvPr/>
         </p:nvSpPr>
         <p:spPr>
           <a:xfrm>
-            <a:off x="1497981" y="108953"/>
-            <a:ext cx="1712112" cy="217905"/>
+            <a:off x="960120" y="128016"/>
+            <a:ext cx="2011680" cy="256032"/>
           </a:xfrm>
           <a:prstGeom prst="rect">
             <a:avLst/>
@@ -9085,7 +9212,7 @@
               <a:buNone/>
             </a:pPr>
             <a:r>
-              <a:rPr lang="en-US" sz="770" dirty="0">
+              <a:rPr lang="en-US" sz="900" dirty="0">
                 <a:solidFill>
                   <a:srgbClr val="5F7183"/>
                 </a:solidFill>
@@ -9095,7 +9222,7 @@
               </a:rPr>
               <a:t>Tiết 2 · 第 2 節</a:t>
             </a:r>
-            <a:endParaRPr lang="en-US" sz="770" dirty="0"/>
+            <a:endParaRPr lang="en-US" sz="900" dirty="0"/>
           </a:p>
         </p:txBody>
       </p:sp>

</xml_diff>

<commit_message>
Week 8 labeling page: move/resize handles on the selected box, arrow-key nudging
Co-Authored-By: Claude Opus 5.5 <noreply@anthropic.com>
</commit_message>
<xml_diff>
--- a/第八週(10-29)/第八週_第2節_簡報.pptx
+++ b/第八週(10-29)/第八週_第2節_簡報.pptx
@@ -3342,7 +3342,29 @@
                 <a:ea typeface="Arial Unicode MS"/>
                 <a:cs typeface="Arial Unicode MS"/>
               </a:rPr>
-              <a:t>，就畫出一個框。畫錯了，點一下那個框選起來，按「刪掉」，或直接按另一個類別改掉。
+              <a:t>，就畫出一個框。畫好的框不夠貼？點一下那個框選起來，框的四個角和四邊會出現</a:t>
+            </a:r>
+            <a:r>
+              <a:rPr sz="1500" b="1" lang="zh-TW" dirty="0">
+                <a:solidFill>
+                  <a:srgbClr val="000000"/>
+                </a:solidFill>
+                <a:latin typeface="Arial Unicode MS"/>
+                <a:ea typeface="Arial Unicode MS"/>
+                <a:cs typeface="Arial Unicode MS"/>
+              </a:rPr>
+              <a:t>白色小方塊</a:t>
+            </a:r>
+            <a:r>
+              <a:rPr sz="1500" lang="zh-TW" dirty="0">
+                <a:solidFill>
+                  <a:srgbClr val="000000"/>
+                </a:solidFill>
+                <a:latin typeface="Arial Unicode MS"/>
+                <a:ea typeface="Arial Unicode MS"/>
+                <a:cs typeface="Arial Unicode MS"/>
+              </a:rPr>
+              <a:t>：拖小方塊可以調大小，拖框的中間可以整個移動；用電腦的話，方向鍵可以一格一格微調。畫錯了，選起來按「刪掉」，或直接按另一個類別改掉。
 </a:t>
             </a:r>
           </a:p>

</xml_diff>

<commit_message>
Week 8 labeling page: reliable box selection (click tolerance, cycle through overlapping boxes, new boxes not auto-selected)
Co-Authored-By: Claude Opus 5.5 <noreply@anthropic.com>
</commit_message>
<xml_diff>
--- a/第八週(10-29)/第八週_第2節_簡報.pptx
+++ b/第八週(10-29)/第八週_第2節_簡報.pptx
@@ -3364,7 +3364,29 @@
                 <a:ea typeface="Arial Unicode MS"/>
                 <a:cs typeface="Arial Unicode MS"/>
               </a:rPr>
-              <a:t>：拖小方塊可以調大小，拖框的中間可以整個移動；用電腦的話，方向鍵可以一格一格微調。畫錯了，選起來按「刪掉」，或直接按另一個類別改掉。
+              <a:t>：拖小方塊可以調大小，拖框的中間可以整個移動；用電腦的話，方向鍵可以一格一格微調。行人常常疊在一起：在同一個地方</a:t>
+            </a:r>
+            <a:r>
+              <a:rPr sz="1500" b="1" lang="zh-TW" dirty="0">
+                <a:solidFill>
+                  <a:srgbClr val="000000"/>
+                </a:solidFill>
+                <a:latin typeface="Arial Unicode MS"/>
+                <a:ea typeface="Arial Unicode MS"/>
+                <a:cs typeface="Arial Unicode MS"/>
+              </a:rPr>
+              <a:t>再點一下</a:t>
+            </a:r>
+            <a:r>
+              <a:rPr sz="1500" lang="zh-TW" dirty="0">
+                <a:solidFill>
+                  <a:srgbClr val="000000"/>
+                </a:solidFill>
+                <a:latin typeface="Arial Unicode MS"/>
+                <a:ea typeface="Arial Unicode MS"/>
+                <a:cs typeface="Arial Unicode MS"/>
+              </a:rPr>
+              <a:t>，就會換選下面那個框。剛畫好的框不會自動選起來，所以可以接著在旁邊畫下一個。畫錯了，選起來按「刪掉」，或直接按另一個類別改掉。
 </a:t>
             </a:r>
           </a:p>

</xml_diff>